<commit_message>
Add report files and update dataset documentation
- Introduced new files for report generation including .aux, .bbl, .out, and .pdf.
- Added .DS_Store files for report directory.
- Updated main.tex with improved abstract and methodological notes.
- Enhanced make_slides.py to reflect changes in reference generation.
- Revised dataset documentation to clarify the use of GPT-4 for generating reference summaries with search-enabled retrieval.
</commit_message>
<xml_diff>
--- a/report/slides/ANLP_slides.pptx
+++ b/report/slides/ANLP_slides.pptx
@@ -3398,7 +3398,7 @@
                 </a:solidFill>
                 <a:latin typeface="Calibri"/>
               </a:rPr>
-              <a:t>GPT-4-generated references → scores measure agreement with GPT-4 style, not a human gold standard.</a:t>
+              <a:t>Search-grounded GPT-4 references → facts anchored in web reports, but still ungrounded in the transcript, stylistically homogeneous, and not exactly reproducible (search results drift).</a:t>
             </a:r>
           </a:p>
           <a:p>
@@ -3927,7 +3927,7 @@
                 </a:solidFill>
                 <a:latin typeface="Calibri"/>
               </a:rPr>
-              <a:t>GPT-4 prompted per match identifier to produce a fixed-template report (~300 words). A pragmatic, disclosed compromise — no human summaries exist for radio commentary.</a:t>
+              <a:t>GPT-4 (ChatGPT web, search enabled) prompted per match identifier; facts grounded in web-retrieved match reports, BBC sourcing verified for every match; fixed template, ~300 words. A pragmatic, disclosed compromise — no human summaries exist for radio commentary.</a:t>
             </a:r>
           </a:p>
           <a:p>

</xml_diff>

<commit_message>
Add bootstrap CIs, faithfulness probes, and clean LED re-scoring to report
- Bootstrap 95% CIs (10k resamples) on all ROUGE results; paired bootstrap
  vs finetuned_bart: all prompting conditions significantly below, BART-LED
  gap (+0.029 [-0.014,+0.070]) not significant
- Rule-based faithfulness metrics (score accuracy, scorer recall): the
  ROUGE-best model states the correct score in 0/9 test matches
- finetuned_led re-scored on the clean 9-match protocol (RL 0.2185) from
  saved run3 predictions, fixing the leaderboard comparability issue
- Updated slides and leaderboard chart (CI whiskers); rebuilt PDF and deck

Co-Authored-By: Claude Fable 5 <noreply@anthropic.com>
</commit_message>
<xml_diff>
--- a/report/slides/ANLP_slides.pptx
+++ b/report/slides/ANLP_slides.pptx
@@ -3341,7 +3341,7 @@
                 </a:solidFill>
                 <a:latin typeface="Calibri"/>
               </a:rPr>
-              <a:t>3.  Surface metrics cannot see the failure that matters </a:t>
+              <a:t>3.  ROUGE and factual accuracy fully decouple at the top </a:t>
             </a:r>
             <a:r>
               <a:rPr sz="1700" b="0" i="0">
@@ -3350,7 +3350,7 @@
                 </a:solidFill>
                 <a:latin typeface="Calibri"/>
               </a:rPr>
-              <a:t>— fluent, confidently wrong match reports score well on ROUGE. Faithfulness evaluation is the natural next step.</a:t>
+              <a:t>— the ROUGE-best model never states the correct score (0/9). Optimising a faithfulness signal, not just measuring one, is the natural next step.</a:t>
             </a:r>
           </a:p>
           <a:p>
@@ -3414,7 +3414,7 @@
                 </a:solidFill>
                 <a:latin typeface="Calibri"/>
               </a:rPr>
-              <a:t>n = 9 test matches → differences within ±0.02 ROUGE-L are noise; no significance testing.</a:t>
+              <a:t>n = 9 test matches → bootstrap CIs resolve fine-tuning vs prompting (significant) but not BART vs LED (+0.029 [−0.014, +0.070]).</a:t>
             </a:r>
           </a:p>
           <a:p>
@@ -3446,7 +3446,7 @@
                 </a:solidFill>
                 <a:latin typeface="Calibri"/>
               </a:rPr>
-              <a:t>Fine-tuned LED not re-trained after the dataset fix → its 0.219 is a valid-only re-evaluation.</a:t>
+              <a:t>Faithfulness probes are recall-oriented: entity precision (invented names, dates, stadiums) is still unmeasured. LED was trained pre-fix (evaluation is clean; training data was not).</a:t>
             </a:r>
           </a:p>
         </p:txBody>
@@ -4578,7 +4578,7 @@
                 </a:solidFill>
                 <a:latin typeface="Calibri"/>
               </a:rPr>
-              <a:t>Results: fine-tuning wins by a wide margin</a:t>
+              <a:t>Results: fine-tuning wins, and the gap is significant</a:t>
             </a:r>
           </a:p>
           <a:p>
@@ -4589,7 +4589,7 @@
                 </a:solidFill>
                 <a:latin typeface="Calibri"/>
               </a:rPr>
-              <a:t>Test ROUGE-L, clean 9-match test set (run 4)</a:t>
+              <a:t>Test ROUGE-L on the clean 9-match test set, bootstrap 95% CIs (10,000 resamples)</a:t>
             </a:r>
           </a:p>
         </p:txBody>
@@ -4610,8 +4610,8 @@
         </p:blipFill>
         <p:spPr>
           <a:xfrm>
-            <a:off x="1005840" y="1325880"/>
-            <a:ext cx="10149840" cy="5258351"/>
+            <a:off x="1234440" y="1280160"/>
+            <a:ext cx="9692640" cy="5255046"/>
           </a:xfrm>
           <a:prstGeom prst="rect">
             <a:avLst/>
@@ -4626,8 +4626,8 @@
         </p:nvSpPr>
         <p:spPr>
           <a:xfrm>
-            <a:off x="640080" y="6172200"/>
-            <a:ext cx="10972800" cy="548640"/>
+            <a:off x="640080" y="6053328"/>
+            <a:ext cx="10972800" cy="685800"/>
           </a:xfrm>
           <a:prstGeom prst="rect">
             <a:avLst/>
@@ -4647,7 +4647,7 @@
                 </a:solidFill>
                 <a:latin typeface="Calibri"/>
               </a:rPr>
-              <a:t>* Fine-tuned LED trained before the dataset fix; scored on the 5 valid-reference test matches — close, but not strictly comparable to the 9-match protocol of the other rows.</a:t>
+              <a:t>Every prompting condition is significantly below fine-tuned BART (paired bootstrap; 95% CI of the difference excludes 0). The BART−LED gap (+0.029 [−0.014, +0.070]) is NOT significant.  * LED trained before the dataset fix; re-scored post-hoc on the same clean 9-match protocol.</a:t>
             </a:r>
           </a:p>
         </p:txBody>
@@ -5467,7 +5467,7 @@
         </p:nvSpPr>
         <p:spPr>
           <a:xfrm>
-            <a:off x="548640" y="3794760"/>
+            <a:off x="548640" y="3749039"/>
             <a:ext cx="11064240" cy="5120640"/>
           </a:xfrm>
           <a:prstGeom prst="rect">
@@ -5487,13 +5487,40 @@
               </a:spcAft>
             </a:pPr>
             <a:r>
-              <a:rPr sz="1700" b="1" i="0">
-                <a:solidFill>
-                  <a:srgbClr val="222222"/>
-                </a:solidFill>
-                <a:latin typeface="Calibri"/>
-              </a:rPr>
-              <a:t>Perfect surface form — score line, date line, report prose — with the year, stadium, competition and result all invented.</a:t>
+              <a:rPr sz="1600" b="1" i="0">
+                <a:solidFill>
+                  <a:srgbClr val="B00000"/>
+                </a:solidFill>
+                <a:latin typeface="Calibri"/>
+              </a:rPr>
+              <a:t>Quantified over all 9 test matches: </a:t>
+            </a:r>
+            <a:r>
+              <a:rPr sz="1600" b="0" i="0">
+                <a:solidFill>
+                  <a:srgbClr val="222222"/>
+                </a:solidFill>
+                <a:latin typeface="Calibri"/>
+              </a:rPr>
+              <a:t>the ROUGE-best model (fine-tuned BART) states the correct final score in </a:t>
+            </a:r>
+            <a:r>
+              <a:rPr sz="1600" b="1" i="0">
+                <a:solidFill>
+                  <a:srgbClr val="B00000"/>
+                </a:solidFill>
+                <a:latin typeface="Calibri"/>
+              </a:rPr>
+              <a:t>0 of 9 matches</a:t>
+            </a:r>
+            <a:r>
+              <a:rPr sz="1600" b="0" i="0">
+                <a:solidFill>
+                  <a:srgbClr val="222222"/>
+                </a:solidFill>
+                <a:latin typeface="Calibri"/>
+              </a:rPr>
+              <a:t> and recalls only 30% of gold scorers. Fine-tuned LED: 1/9 scores, 15% scorers.</a:t>
             </a:r>
           </a:p>
           <a:p>
@@ -5503,22 +5530,13 @@
               </a:spcAft>
             </a:pPr>
             <a:r>
-              <a:rPr sz="1700" b="1" i="0">
-                <a:solidFill>
-                  <a:srgbClr val="B00000"/>
-                </a:solidFill>
-                <a:latin typeface="Calibri"/>
-              </a:rPr>
-              <a:t>ROUGE rewards it anyway: </a:t>
-            </a:r>
-            <a:r>
-              <a:rPr sz="1700" b="0" i="0">
-                <a:solidFill>
-                  <a:srgbClr val="222222"/>
-                </a:solidFill>
-                <a:latin typeface="Calibri"/>
-              </a:rPr>
-              <a:t>the n-grams that overlap with the reference (team names, date formats, “in the Xth minute”) are exactly what the models do reproduce; hallucinated facts cost nothing.</a:t>
+              <a:rPr sz="1600" b="0" i="0">
+                <a:solidFill>
+                  <a:srgbClr val="222222"/>
+                </a:solidFill>
+                <a:latin typeface="Calibri"/>
+              </a:rPr>
+              <a:t>Perfect surface form — score line, date line, report prose — with the facts invented. ROUGE rewards it anyway: the overlapping n-grams (team names, date formats, “in the Xth minute”) are exactly what the models do reproduce; wrong facts cost nothing.</a:t>
             </a:r>
           </a:p>
           <a:p>
@@ -5528,13 +5546,13 @@
               </a:spcAft>
             </a:pPr>
             <a:r>
-              <a:rPr sz="1700" b="0" i="0">
-                <a:solidFill>
-                  <a:srgbClr val="222222"/>
-                </a:solidFill>
-                <a:latin typeface="Calibri"/>
-              </a:rPr>
-              <a:t>Prompted baselines fail differently: FLAN emits template fragments; LED continues the commentary instead of summarising it.</a:t>
+              <a:rPr sz="1600" b="0" i="0">
+                <a:solidFill>
+                  <a:srgbClr val="222222"/>
+                </a:solidFill>
+                <a:latin typeface="Calibri"/>
+              </a:rPr>
+              <a:t>Prompted baselines fail earlier: FLAN and BART few-shot don’t even name both teams (they copy the in-context example’s teams).</a:t>
             </a:r>
           </a:p>
         </p:txBody>

</xml_diff>

<commit_message>
Add semantic metrics (BERTScore + NLI grounding), remove release claim
- BERTScore F1 vs references (RoBERTa-large, local): reproduces the ROUGE
  ranking, confirming fine-tuning gains are not an n-gram artefact
- NLI support rate vs transcript (DeBERTa-MNLI + TF-IDF retrieval): inverts
  the ranking — fine-tuned BART has 0% of sentences entailed by the source
  vs 34% for prompted long-context LED; new Section 6.4 discusses the
  reference-similarity vs source-grounding trade-off
- Replace "BERTScore not reported" limitation with NLI caveats
- Sweep "gold" -> "reference" (no human gold standard is implied)
- Remove "released under permissive licensing" claim (dataset stays private)
- Update slides (finding 3, limitations); rebuild PDF and deck

Co-Authored-By: Claude Fable 5 <noreply@anthropic.com>
</commit_message>
<xml_diff>
--- a/report/slides/ANLP_slides.pptx
+++ b/report/slides/ANLP_slides.pptx
@@ -3446,7 +3446,7 @@
                 </a:solidFill>
                 <a:latin typeface="Calibri"/>
               </a:rPr>
-              <a:t>Faithfulness probes are recall-oriented: entity precision (invented names, dates, stadiums) is still unmeasured. LED was trained pre-fix (evaluation is clean; training data was not).</a:t>
+              <a:t>NLI support rates are conservative lower bounds (ASR-noisy premises, register gap); entity precision is still unmeasured. LED was trained pre-fix (evaluation clean, training not).</a:t>
             </a:r>
           </a:p>
         </p:txBody>
@@ -5487,7 +5487,7 @@
               </a:spcAft>
             </a:pPr>
             <a:r>
-              <a:rPr sz="1600" b="1" i="0">
+              <a:rPr sz="1500" b="1" i="0">
                 <a:solidFill>
                   <a:srgbClr val="B00000"/>
                 </a:solidFill>
@@ -5496,16 +5496,16 @@
               <a:t>Quantified over all 9 test matches: </a:t>
             </a:r>
             <a:r>
-              <a:rPr sz="1600" b="0" i="0">
-                <a:solidFill>
-                  <a:srgbClr val="222222"/>
-                </a:solidFill>
-                <a:latin typeface="Calibri"/>
-              </a:rPr>
-              <a:t>the ROUGE-best model (fine-tuned BART) states the correct final score in </a:t>
-            </a:r>
-            <a:r>
-              <a:rPr sz="1600" b="1" i="0">
+              <a:rPr sz="1500" b="0" i="0">
+                <a:solidFill>
+                  <a:srgbClr val="222222"/>
+                </a:solidFill>
+                <a:latin typeface="Calibri"/>
+              </a:rPr>
+              <a:t>the ROUGE- and BERTScore-best model (fine-tuned BART) states the correct final score in </a:t>
+            </a:r>
+            <a:r>
+              <a:rPr sz="1500" b="1" i="0">
                 <a:solidFill>
                   <a:srgbClr val="B00000"/>
                 </a:solidFill>
@@ -5514,13 +5514,31 @@
               <a:t>0 of 9 matches</a:t>
             </a:r>
             <a:r>
-              <a:rPr sz="1600" b="0" i="0">
-                <a:solidFill>
-                  <a:srgbClr val="222222"/>
-                </a:solidFill>
-                <a:latin typeface="Calibri"/>
-              </a:rPr>
-              <a:t> and recalls only 30% of gold scorers. Fine-tuned LED: 1/9 scores, 15% scorers.</a:t>
+              <a:rPr sz="1500" b="0" i="0">
+                <a:solidFill>
+                  <a:srgbClr val="222222"/>
+                </a:solidFill>
+                <a:latin typeface="Calibri"/>
+              </a:rPr>
+              <a:t>, recalls 30% of reference scorers, and has </a:t>
+            </a:r>
+            <a:r>
+              <a:rPr sz="1500" b="1" i="0">
+                <a:solidFill>
+                  <a:srgbClr val="B00000"/>
+                </a:solidFill>
+                <a:latin typeface="Calibri"/>
+              </a:rPr>
+              <a:t>0% of sentences NLI-entailed by the transcript</a:t>
+            </a:r>
+            <a:r>
+              <a:rPr sz="1500" b="0" i="0">
+                <a:solidFill>
+                  <a:srgbClr val="222222"/>
+                </a:solidFill>
+                <a:latin typeface="Calibri"/>
+              </a:rPr>
+              <a:t>. Fine-tuned LED: 1/9 scores, 15% scorers, 3% entailed.</a:t>
             </a:r>
           </a:p>
           <a:p>
@@ -5530,13 +5548,22 @@
               </a:spcAft>
             </a:pPr>
             <a:r>
-              <a:rPr sz="1600" b="0" i="0">
-                <a:solidFill>
-                  <a:srgbClr val="222222"/>
-                </a:solidFill>
-                <a:latin typeface="Calibri"/>
-              </a:rPr>
-              <a:t>Perfect surface form — score line, date line, report prose — with the facts invented. ROUGE rewards it anyway: the overlapping n-grams (team names, date formats, “in the Xth minute”) are exactly what the models do reproduce; wrong facts cost nothing.</a:t>
+              <a:rPr sz="1500" b="1" i="0">
+                <a:solidFill>
+                  <a:srgbClr val="222222"/>
+                </a:solidFill>
+                <a:latin typeface="Calibri"/>
+              </a:rPr>
+              <a:t>The rankings invert: </a:t>
+            </a:r>
+            <a:r>
+              <a:rPr sz="1500" b="0" i="0">
+                <a:solidFill>
+                  <a:srgbClr val="222222"/>
+                </a:solidFill>
+                <a:latin typeface="Calibri"/>
+              </a:rPr>
+              <a:t>prompted long-context LED — bottom of every reference-based metric — is the best-grounded condition (34% of sentences entailed), because it copies the commentary it reads. Fine-tuning optimises agreement with the references at the expense of grounding in the input.</a:t>
             </a:r>
           </a:p>
           <a:p>
@@ -5546,13 +5573,13 @@
               </a:spcAft>
             </a:pPr>
             <a:r>
-              <a:rPr sz="1600" b="0" i="0">
-                <a:solidFill>
-                  <a:srgbClr val="222222"/>
-                </a:solidFill>
-                <a:latin typeface="Calibri"/>
-              </a:rPr>
-              <a:t>Prompted baselines fail earlier: FLAN and BART few-shot don’t even name both teams (they copy the in-context example’s teams).</a:t>
+              <a:rPr sz="1500" b="0" i="0">
+                <a:solidFill>
+                  <a:srgbClr val="222222"/>
+                </a:solidFill>
+                <a:latin typeface="Calibri"/>
+              </a:rPr>
+              <a:t>ROUGE and BERTScore reward the hallucination: overlapping n-grams and semantics (team names, date formats, report style) are exactly what the models reproduce; wrong facts cost nothing.</a:t>
             </a:r>
           </a:p>
         </p:txBody>

</xml_diff>

<commit_message>
Restructure slides: dedicated inversion slide, honest Finding 2, trim slide 4
- New slide 9 (Finding 4): two-panel dot plot of BERTScore-vs-reference and
  NLI-support-vs-transcript showing the reference/source inversion
- Finding 2 retitled "ties at fine-tuning" to match the non-significant
  paired bootstrap result; bullets updated with CI nuance
- Finding 3 slimmed to the factual probes (inversion moved to its own slide)
- Slide 4 methodology bullets trimmed; conclusions takeaway 3 updated
- Deck is now 11 slides; palette for new chart validated (dataviz checks)

Co-Authored-By: Claude Fable 5 <noreply@anthropic.com>
</commit_message>
<xml_diff>
--- a/report/slides/ANLP_slides.pptx
+++ b/report/slides/ANLP_slides.pptx
@@ -15,6 +15,7 @@
     <p:sldId id="263" r:id="rId14"/>
     <p:sldId id="264" r:id="rId15"/>
     <p:sldId id="265" r:id="rId16"/>
+    <p:sldId id="266" r:id="rId17"/>
   </p:sldIdLst>
   <p:sldSz cx="12191695" cy="6858000" type="screen4x3"/>
   <p:notesSz cx="6858000" cy="9144000"/>
@@ -3252,6 +3253,285 @@
                 </a:solidFill>
                 <a:latin typeface="Calibri"/>
               </a:rPr>
+              <a:t>The biggest improvement was not a model change</a:t>
+            </a:r>
+          </a:p>
+          <a:p>
+            <a:r>
+              <a:rPr sz="1300" b="0" i="0">
+                <a:solidFill>
+                  <a:srgbClr val="C9D8EC"/>
+                </a:solidFill>
+                <a:latin typeface="Calibri"/>
+              </a:rPr>
+              <a:t>Five silent LED training failures + one dataset bug</a:t>
+            </a:r>
+          </a:p>
+        </p:txBody>
+      </p:sp>
+      <p:sp>
+        <p:nvSpPr>
+          <p:cNvPr id="3" name="TextBox 2"/>
+          <p:cNvSpPr txBox="1"/>
+          <p:nvPr/>
+        </p:nvSpPr>
+        <p:spPr>
+          <a:xfrm>
+            <a:off x="548640" y="1325880"/>
+            <a:ext cx="5760720" cy="5120640"/>
+          </a:xfrm>
+          <a:prstGeom prst="rect">
+            <a:avLst/>
+          </a:prstGeom>
+          <a:noFill/>
+        </p:spPr>
+        <p:txBody>
+          <a:bodyPr wrap="square">
+            <a:spAutoFit/>
+          </a:bodyPr>
+          <a:lstStyle/>
+          <a:p>
+            <a:pPr>
+              <a:spcAft>
+                <a:spcPts val="800"/>
+              </a:spcAft>
+            </a:pPr>
+            <a:r>
+              <a:rPr sz="1600" b="1" i="0">
+                <a:solidFill>
+                  <a:srgbClr val="B00000"/>
+                </a:solidFill>
+                <a:latin typeface="Calibri"/>
+              </a:rPr>
+              <a:t>33% of training references were 0-byte files </a:t>
+            </a:r>
+            <a:r>
+              <a:rPr sz="1600" b="0" i="0">
+                <a:solidFill>
+                  <a:srgbClr val="222222"/>
+                </a:solidFill>
+                <a:latin typeface="Calibri"/>
+              </a:rPr>
+              <a:t>(and 44% of test references) — silently teaching models to emit empty strings and deflating every score ~1.8×.</a:t>
+            </a:r>
+          </a:p>
+          <a:p>
+            <a:pPr>
+              <a:spcAft>
+                <a:spcPts val="800"/>
+              </a:spcAft>
+            </a:pPr>
+            <a:r>
+              <a:rPr sz="1600" b="0" i="0">
+                <a:solidFill>
+                  <a:srgbClr val="222222"/>
+                </a:solidFill>
+                <a:latin typeface="Calibri"/>
+              </a:rPr>
+              <a:t>Predicted correction ratio matched the measured one almost exactly (e.g. fine-tuned BART 0.136 → 0.248 after the fix).</a:t>
+            </a:r>
+          </a:p>
+          <a:p>
+            <a:pPr>
+              <a:spcAft>
+                <a:spcPts val="800"/>
+              </a:spcAft>
+            </a:pPr>
+            <a:r>
+              <a:rPr sz="1600" b="1" i="0">
+                <a:solidFill>
+                  <a:srgbClr val="222222"/>
+                </a:solidFill>
+                <a:latin typeface="Calibri"/>
+              </a:rPr>
+              <a:t>LED also needed 5 bug fixes </a:t>
+            </a:r>
+            <a:r>
+              <a:rPr sz="1600" b="0" i="0">
+                <a:solidFill>
+                  <a:srgbClr val="222222"/>
+                </a:solidFill>
+                <a:latin typeface="Calibri"/>
+              </a:rPr>
+              <a:t>(defeated random-window sampler, collapse-to-EOS, decoder sentinel overflow, lost checkpoint, CLI truncation).</a:t>
+            </a:r>
+          </a:p>
+          <a:p>
+            <a:pPr>
+              <a:spcAft>
+                <a:spcPts val="800"/>
+              </a:spcAft>
+            </a:pPr>
+            <a:r>
+              <a:rPr sz="1600" b="1" i="0">
+                <a:solidFill>
+                  <a:srgbClr val="0A3D7A"/>
+                </a:solidFill>
+                <a:latin typeface="Calibri"/>
+              </a:rPr>
+              <a:t>After the fixes: a clean, monotone training curve → the earlier collapses were data and code defects, not modelling limits.</a:t>
+            </a:r>
+          </a:p>
+        </p:txBody>
+      </p:sp>
+      <p:pic>
+        <p:nvPicPr>
+          <p:cNvPr id="4" name="Picture 3" descr="led_training_curve.png"/>
+          <p:cNvPicPr>
+            <a:picLocks noChangeAspect="1"/>
+          </p:cNvPicPr>
+          <p:nvPr/>
+        </p:nvPicPr>
+        <p:blipFill>
+          <a:blip r:embed="rId2"/>
+          <a:stretch>
+            <a:fillRect/>
+          </a:stretch>
+        </p:blipFill>
+        <p:spPr>
+          <a:xfrm>
+            <a:off x="6537960" y="1737360"/>
+            <a:ext cx="5212080" cy="2932191"/>
+          </a:xfrm>
+          <a:prstGeom prst="rect">
+            <a:avLst/>
+          </a:prstGeom>
+        </p:spPr>
+      </p:pic>
+      <p:sp>
+        <p:nvSpPr>
+          <p:cNvPr id="5" name="TextBox 4"/>
+          <p:cNvSpPr txBox="1"/>
+          <p:nvPr/>
+        </p:nvSpPr>
+        <p:spPr>
+          <a:xfrm>
+            <a:off x="6537960" y="5166360"/>
+            <a:ext cx="5212080" cy="457200"/>
+          </a:xfrm>
+          <a:prstGeom prst="rect">
+            <a:avLst/>
+          </a:prstGeom>
+          <a:noFill/>
+        </p:spPr>
+        <p:txBody>
+          <a:bodyPr wrap="square">
+            <a:spAutoFit/>
+          </a:bodyPr>
+          <a:lstStyle/>
+          <a:p>
+            <a:r>
+              <a:rPr sz="1200" b="0" i="1">
+                <a:solidFill>
+                  <a:srgbClr val="666666"/>
+                </a:solidFill>
+                <a:latin typeface="Calibri"/>
+              </a:rPr>
+              <a:t>LED fine-tuning after the fixes: val ROUGE-L peaks at 0.172 (epoch 9).</a:t>
+            </a:r>
+          </a:p>
+        </p:txBody>
+      </p:sp>
+      <p:sp>
+        <p:nvSpPr>
+          <p:cNvPr id="6" name="TextBox 5"/>
+          <p:cNvSpPr txBox="1"/>
+          <p:nvPr/>
+        </p:nvSpPr>
+        <p:spPr>
+          <a:xfrm>
+            <a:off x="11277295" y="6473952"/>
+            <a:ext cx="731520" cy="274320"/>
+          </a:xfrm>
+          <a:prstGeom prst="rect">
+            <a:avLst/>
+          </a:prstGeom>
+          <a:noFill/>
+        </p:spPr>
+        <p:txBody>
+          <a:bodyPr wrap="square">
+            <a:spAutoFit/>
+          </a:bodyPr>
+          <a:lstStyle/>
+          <a:p>
+            <a:pPr algn="r"/>
+            <a:r>
+              <a:rPr sz="1100" b="0" i="0">
+                <a:solidFill>
+                  <a:srgbClr val="666666"/>
+                </a:solidFill>
+                <a:latin typeface="Calibri"/>
+              </a:rPr>
+              <a:t>10</a:t>
+            </a:r>
+          </a:p>
+        </p:txBody>
+      </p:sp>
+    </p:spTree>
+  </p:cSld>
+  <p:clrMapOvr>
+    <a:masterClrMapping/>
+  </p:clrMapOvr>
+</p:sld>
+</file>
+
+<file path=ppt/slides/slide11.xml><?xml version="1.0" encoding="utf-8"?>
+<p:sld xmlns:a="http://schemas.openxmlformats.org/drawingml/2006/main" xmlns:p="http://schemas.openxmlformats.org/presentationml/2006/main" xmlns:r="http://schemas.openxmlformats.org/officeDocument/2006/relationships">
+  <p:cSld>
+    <p:spTree>
+      <p:nvGrpSpPr>
+        <p:cNvPr id="1" name=""/>
+        <p:cNvGrpSpPr/>
+        <p:nvPr/>
+      </p:nvGrpSpPr>
+      <p:grpSpPr/>
+      <p:sp>
+        <p:nvSpPr>
+          <p:cNvPr id="2" name="Rectangle 1"/>
+          <p:cNvSpPr/>
+          <p:nvPr/>
+        </p:nvSpPr>
+        <p:spPr>
+          <a:xfrm>
+            <a:off x="0" y="0"/>
+            <a:ext cx="12191695" cy="1005840"/>
+          </a:xfrm>
+          <a:prstGeom prst="rect">
+            <a:avLst/>
+          </a:prstGeom>
+          <a:solidFill>
+            <a:srgbClr val="0A3D7A"/>
+          </a:solidFill>
+          <a:ln>
+            <a:noFill/>
+          </a:ln>
+        </p:spPr>
+        <p:style>
+          <a:lnRef idx="1">
+            <a:schemeClr val="accent1"/>
+          </a:lnRef>
+          <a:fillRef idx="3">
+            <a:schemeClr val="accent1"/>
+          </a:fillRef>
+          <a:effectRef idx="2">
+            <a:schemeClr val="accent1"/>
+          </a:effectRef>
+          <a:fontRef idx="minor">
+            <a:schemeClr val="lt1"/>
+          </a:fontRef>
+        </p:style>
+        <p:txBody>
+          <a:bodyPr rtlCol="0" anchor="ctr" wrap="square" lIns="502920" tIns="109728"/>
+          <a:lstStyle/>
+          <a:p>
+            <a:pPr algn="ctr"/>
+            <a:r>
+              <a:rPr sz="2700" b="1" i="0">
+                <a:solidFill>
+                  <a:srgbClr val="FFFFFF"/>
+                </a:solidFill>
+                <a:latin typeface="Calibri"/>
+              </a:rPr>
               <a:t>Conclusions &amp; limitations</a:t>
             </a:r>
           </a:p>
@@ -3341,7 +3621,7 @@
                 </a:solidFill>
                 <a:latin typeface="Calibri"/>
               </a:rPr>
-              <a:t>3.  ROUGE and factual accuracy fully decouple at the top </a:t>
+              <a:t>3.  Reference similarity and source grounding fully decouple </a:t>
             </a:r>
             <a:r>
               <a:rPr sz="1700" b="0" i="0">
@@ -3350,7 +3630,7 @@
                 </a:solidFill>
                 <a:latin typeface="Calibri"/>
               </a:rPr>
-              <a:t>— the ROUGE-best model never states the correct score (0/9). Optimising a faithfulness signal, not just measuring one, is the natural next step.</a:t>
+              <a:t>— the ROUGE- and BERTScore-best model never states the correct score (0/9) and has 0% of sentences entailed by the transcript. Optimising a faithfulness signal, not just measuring one, is the natural next step.</a:t>
             </a:r>
           </a:p>
           <a:p>
@@ -3481,7 +3761,7 @@
                 </a:solidFill>
                 <a:latin typeface="Calibri"/>
               </a:rPr>
-              <a:t>10</a:t>
+              <a:t>11</a:t>
             </a:r>
           </a:p>
         </p:txBody>
@@ -4397,7 +4677,7 @@
         </p:nvSpPr>
         <p:spPr>
           <a:xfrm>
-            <a:off x="548640" y="4572000"/>
+            <a:off x="548640" y="4663440"/>
             <a:ext cx="11064240" cy="5120640"/>
           </a:xfrm>
           <a:prstGeom prst="rect">
@@ -4432,7 +4712,25 @@
                 </a:solidFill>
                 <a:latin typeface="Calibri"/>
               </a:rPr>
-              <a:t>segment-aligned chunks with 1-segment overlap → per-chunk summary → merge → BoW-cosine dedup.</a:t>
+              <a:t>segment-aligned chunks → per-chunk summary → merge + dedup.   </a:t>
+            </a:r>
+            <a:r>
+              <a:rPr sz="1600" b="1" i="0">
+                <a:solidFill>
+                  <a:srgbClr val="222222"/>
+                </a:solidFill>
+                <a:latin typeface="Calibri"/>
+              </a:rPr>
+              <a:t>Long-context: </a:t>
+            </a:r>
+            <a:r>
+              <a:rPr sz="1600" b="0" i="0">
+                <a:solidFill>
+                  <a:srgbClr val="222222"/>
+                </a:solidFill>
+                <a:latin typeface="Calibri"/>
+              </a:rPr>
+              <a:t>whole transcript in one LED pass.</a:t>
             </a:r>
           </a:p>
           <a:p>
@@ -4442,38 +4740,13 @@
               </a:spcAft>
             </a:pPr>
             <a:r>
-              <a:rPr sz="1600" b="1" i="0">
-                <a:solidFill>
-                  <a:srgbClr val="222222"/>
-                </a:solidFill>
-                <a:latin typeface="Calibri"/>
-              </a:rPr>
-              <a:t>Long-context: </a:t>
-            </a:r>
-            <a:r>
               <a:rPr sz="1600" b="0" i="0">
                 <a:solidFill>
                   <a:srgbClr val="222222"/>
                 </a:solidFill>
                 <a:latin typeface="Calibri"/>
               </a:rPr>
-              <a:t>whole transcript in one LED forward pass; global attention on BOS; gradient checkpointing on a T4.</a:t>
-            </a:r>
-          </a:p>
-          <a:p>
-            <a:pPr>
-              <a:spcAft>
-                <a:spcPts val="800"/>
-              </a:spcAft>
-            </a:pPr>
-            <a:r>
-              <a:rPr sz="1600" b="0" i="0">
-                <a:solidFill>
-                  <a:srgbClr val="222222"/>
-                </a:solidFill>
-                <a:latin typeface="Calibri"/>
-              </a:rPr>
-              <a:t>All experiments on free-tier Kaggle (1× T4, 15.6 GB); seeds fixed; every prediction saved to disk.</a:t>
+              <a:t>All experiments on free-tier Kaggle (1× T4); seeds fixed; every prediction saved to disk, so all metrics are recomputable post-hoc.</a:t>
             </a:r>
           </a:p>
         </p:txBody>
@@ -5030,7 +5303,7 @@
                 </a:solidFill>
                 <a:latin typeface="Calibri"/>
               </a:rPr>
-              <a:t>Finding 2 — Long context wins at prompting, loses at fine-tuning</a:t>
+              <a:t>Finding 2 — Long context wins at prompting, ties at fine-tuning</a:t>
             </a:r>
           </a:p>
         </p:txBody>
@@ -5103,7 +5376,7 @@
                 </a:solidFill>
                 <a:latin typeface="Calibri"/>
               </a:rPr>
-              <a:t>the ranking inverts — BART chunk-merger 0.248 vs fine-tuned LED 0.219.</a:t>
+              <a:t>BART chunk-merger is nominally ahead (0.248 vs 0.219) but the paired difference is not significant at n = 9 — the two fine-tuned pipelines cannot be separated. LED is more consistent (narrow CI); BART has the higher ceiling (wide CI).</a:t>
             </a:r>
           </a:p>
           <a:p>
@@ -5135,7 +5408,7 @@
                 </a:solidFill>
                 <a:latin typeface="Calibri"/>
               </a:rPr>
-              <a:t>Why: sample efficiency at N = 80.</a:t>
+              <a:t>Why chunk-merger might really be ahead: sample efficiency at N = 80.</a:t>
             </a:r>
           </a:p>
           <a:p>
@@ -5467,7 +5740,7 @@
         </p:nvSpPr>
         <p:spPr>
           <a:xfrm>
-            <a:off x="548640" y="3749039"/>
+            <a:off x="548640" y="3794760"/>
             <a:ext cx="11064240" cy="5120640"/>
           </a:xfrm>
           <a:prstGeom prst="rect">
@@ -5487,7 +5760,7 @@
               </a:spcAft>
             </a:pPr>
             <a:r>
-              <a:rPr sz="1500" b="1" i="0">
+              <a:rPr sz="1600" b="1" i="0">
                 <a:solidFill>
                   <a:srgbClr val="B00000"/>
                 </a:solidFill>
@@ -5496,16 +5769,16 @@
               <a:t>Quantified over all 9 test matches: </a:t>
             </a:r>
             <a:r>
-              <a:rPr sz="1500" b="0" i="0">
-                <a:solidFill>
-                  <a:srgbClr val="222222"/>
-                </a:solidFill>
-                <a:latin typeface="Calibri"/>
-              </a:rPr>
-              <a:t>the ROUGE- and BERTScore-best model (fine-tuned BART) states the correct final score in </a:t>
-            </a:r>
-            <a:r>
-              <a:rPr sz="1500" b="1" i="0">
+              <a:rPr sz="1600" b="0" i="0">
+                <a:solidFill>
+                  <a:srgbClr val="222222"/>
+                </a:solidFill>
+                <a:latin typeface="Calibri"/>
+              </a:rPr>
+              <a:t>the ROUGE-best model (fine-tuned BART) states the correct final score in </a:t>
+            </a:r>
+            <a:r>
+              <a:rPr sz="1600" b="1" i="0">
                 <a:solidFill>
                   <a:srgbClr val="B00000"/>
                 </a:solidFill>
@@ -5514,31 +5787,13 @@
               <a:t>0 of 9 matches</a:t>
             </a:r>
             <a:r>
-              <a:rPr sz="1500" b="0" i="0">
-                <a:solidFill>
-                  <a:srgbClr val="222222"/>
-                </a:solidFill>
-                <a:latin typeface="Calibri"/>
-              </a:rPr>
-              <a:t>, recalls 30% of reference scorers, and has </a:t>
-            </a:r>
-            <a:r>
-              <a:rPr sz="1500" b="1" i="0">
-                <a:solidFill>
-                  <a:srgbClr val="B00000"/>
-                </a:solidFill>
-                <a:latin typeface="Calibri"/>
-              </a:rPr>
-              <a:t>0% of sentences NLI-entailed by the transcript</a:t>
-            </a:r>
-            <a:r>
-              <a:rPr sz="1500" b="0" i="0">
-                <a:solidFill>
-                  <a:srgbClr val="222222"/>
-                </a:solidFill>
-                <a:latin typeface="Calibri"/>
-              </a:rPr>
-              <a:t>. Fine-tuned LED: 1/9 scores, 15% scorers, 3% entailed.</a:t>
+              <a:rPr sz="1600" b="0" i="0">
+                <a:solidFill>
+                  <a:srgbClr val="222222"/>
+                </a:solidFill>
+                <a:latin typeface="Calibri"/>
+              </a:rPr>
+              <a:t> and recalls only 30% of reference scorers. Fine-tuned LED: 1/9 scores, 15% scorers. Its scorelines are decorative — 1–1, 2–2, 1–0 regardless of the real 0–4, 3–0…</a:t>
             </a:r>
           </a:p>
           <a:p>
@@ -5548,38 +5803,22 @@
               </a:spcAft>
             </a:pPr>
             <a:r>
-              <a:rPr sz="1500" b="1" i="0">
-                <a:solidFill>
-                  <a:srgbClr val="222222"/>
-                </a:solidFill>
-                <a:latin typeface="Calibri"/>
-              </a:rPr>
-              <a:t>The rankings invert: </a:t>
-            </a:r>
-            <a:r>
-              <a:rPr sz="1500" b="0" i="0">
-                <a:solidFill>
-                  <a:srgbClr val="222222"/>
-                </a:solidFill>
-                <a:latin typeface="Calibri"/>
-              </a:rPr>
-              <a:t>prompted long-context LED — bottom of every reference-based metric — is the best-grounded condition (34% of sentences entailed), because it copies the commentary it reads. Fine-tuning optimises agreement with the references at the expense of grounding in the input.</a:t>
-            </a:r>
-          </a:p>
-          <a:p>
-            <a:pPr>
-              <a:spcAft>
-                <a:spcPts val="800"/>
-              </a:spcAft>
-            </a:pPr>
-            <a:r>
-              <a:rPr sz="1500" b="0" i="0">
-                <a:solidFill>
-                  <a:srgbClr val="222222"/>
-                </a:solidFill>
-                <a:latin typeface="Calibri"/>
-              </a:rPr>
-              <a:t>ROUGE and BERTScore reward the hallucination: overlapping n-grams and semantics (team names, date formats, report style) are exactly what the models reproduce; wrong facts cost nothing.</a:t>
+              <a:rPr sz="1600" b="1" i="0">
+                <a:solidFill>
+                  <a:srgbClr val="222222"/>
+                </a:solidFill>
+                <a:latin typeface="Calibri"/>
+              </a:rPr>
+              <a:t>ROUGE rewards the hallucination: </a:t>
+            </a:r>
+            <a:r>
+              <a:rPr sz="1600" b="0" i="0">
+                <a:solidFill>
+                  <a:srgbClr val="222222"/>
+                </a:solidFill>
+                <a:latin typeface="Calibri"/>
+              </a:rPr>
+              <a:t>the overlapping n-grams (team names, date formats, report style) are exactly what the models reproduce; wrong facts cost nothing.</a:t>
             </a:r>
           </a:p>
         </p:txBody>
@@ -5684,7 +5923,7 @@
                 </a:solidFill>
                 <a:latin typeface="Calibri"/>
               </a:rPr>
-              <a:t>The biggest improvement was not a model change</a:t>
+              <a:t>Finding 4 — Models optimise the reference, not the source</a:t>
             </a:r>
           </a:p>
           <a:p>
@@ -5695,119 +5934,14 @@
                 </a:solidFill>
                 <a:latin typeface="Calibri"/>
               </a:rPr>
-              <a:t>Five silent LED training failures + one dataset bug</a:t>
-            </a:r>
-          </a:p>
-        </p:txBody>
-      </p:sp>
-      <p:sp>
-        <p:nvSpPr>
-          <p:cNvPr id="3" name="TextBox 2"/>
-          <p:cNvSpPr txBox="1"/>
-          <p:nvPr/>
-        </p:nvSpPr>
-        <p:spPr>
-          <a:xfrm>
-            <a:off x="548640" y="1325880"/>
-            <a:ext cx="5760720" cy="5120640"/>
-          </a:xfrm>
-          <a:prstGeom prst="rect">
-            <a:avLst/>
-          </a:prstGeom>
-          <a:noFill/>
-        </p:spPr>
-        <p:txBody>
-          <a:bodyPr wrap="square">
-            <a:spAutoFit/>
-          </a:bodyPr>
-          <a:lstStyle/>
-          <a:p>
-            <a:pPr>
-              <a:spcAft>
-                <a:spcPts val="800"/>
-              </a:spcAft>
-            </a:pPr>
-            <a:r>
-              <a:rPr sz="1600" b="1" i="0">
-                <a:solidFill>
-                  <a:srgbClr val="B00000"/>
-                </a:solidFill>
-                <a:latin typeface="Calibri"/>
-              </a:rPr>
-              <a:t>33% of training references were 0-byte files </a:t>
-            </a:r>
-            <a:r>
-              <a:rPr sz="1600" b="0" i="0">
-                <a:solidFill>
-                  <a:srgbClr val="222222"/>
-                </a:solidFill>
-                <a:latin typeface="Calibri"/>
-              </a:rPr>
-              <a:t>(and 44% of test references) — silently teaching models to emit empty strings and deflating every score ~1.8×.</a:t>
-            </a:r>
-          </a:p>
-          <a:p>
-            <a:pPr>
-              <a:spcAft>
-                <a:spcPts val="800"/>
-              </a:spcAft>
-            </a:pPr>
-            <a:r>
-              <a:rPr sz="1600" b="0" i="0">
-                <a:solidFill>
-                  <a:srgbClr val="222222"/>
-                </a:solidFill>
-                <a:latin typeface="Calibri"/>
-              </a:rPr>
-              <a:t>Predicted correction ratio matched the measured one almost exactly (e.g. fine-tuned BART 0.136 → 0.248 after the fix).</a:t>
-            </a:r>
-          </a:p>
-          <a:p>
-            <a:pPr>
-              <a:spcAft>
-                <a:spcPts val="800"/>
-              </a:spcAft>
-            </a:pPr>
-            <a:r>
-              <a:rPr sz="1600" b="1" i="0">
-                <a:solidFill>
-                  <a:srgbClr val="222222"/>
-                </a:solidFill>
-                <a:latin typeface="Calibri"/>
-              </a:rPr>
-              <a:t>LED also needed 5 bug fixes </a:t>
-            </a:r>
-            <a:r>
-              <a:rPr sz="1600" b="0" i="0">
-                <a:solidFill>
-                  <a:srgbClr val="222222"/>
-                </a:solidFill>
-                <a:latin typeface="Calibri"/>
-              </a:rPr>
-              <a:t>(defeated random-window sampler, collapse-to-EOS, decoder sentinel overflow, lost checkpoint, CLI truncation).</a:t>
-            </a:r>
-          </a:p>
-          <a:p>
-            <a:pPr>
-              <a:spcAft>
-                <a:spcPts val="800"/>
-              </a:spcAft>
-            </a:pPr>
-            <a:r>
-              <a:rPr sz="1600" b="1" i="0">
-                <a:solidFill>
-                  <a:srgbClr val="0A3D7A"/>
-                </a:solidFill>
-                <a:latin typeface="Calibri"/>
-              </a:rPr>
-              <a:t>After the fixes: a clean, monotone training curve → the earlier collapses were data and code defects, not modelling limits.</a:t>
+              <a:t>BERTScore vs reference · NLI entailment vs transcript (DeBERTa-MNLI, TF-IDF-retrieved windows)</a:t>
             </a:r>
           </a:p>
         </p:txBody>
       </p:sp>
       <p:pic>
         <p:nvPicPr>
-          <p:cNvPr id="4" name="Picture 3" descr="led_training_curve.png"/>
+          <p:cNvPr id="3" name="Picture 2" descr="inversion.png"/>
           <p:cNvPicPr>
             <a:picLocks noChangeAspect="1"/>
           </p:cNvPicPr>
@@ -5821,8 +5955,8 @@
         </p:blipFill>
         <p:spPr>
           <a:xfrm>
-            <a:off x="6537960" y="1737360"/>
-            <a:ext cx="5212080" cy="2932191"/>
+            <a:off x="1371600" y="1371600"/>
+            <a:ext cx="9418320" cy="3228124"/>
           </a:xfrm>
           <a:prstGeom prst="rect">
             <a:avLst/>
@@ -5831,14 +5965,14 @@
       </p:pic>
       <p:sp>
         <p:nvSpPr>
-          <p:cNvPr id="5" name="TextBox 4"/>
+          <p:cNvPr id="4" name="TextBox 3"/>
           <p:cNvSpPr txBox="1"/>
           <p:nvPr/>
         </p:nvSpPr>
         <p:spPr>
           <a:xfrm>
-            <a:off x="6537960" y="5166360"/>
-            <a:ext cx="5212080" cy="457200"/>
+            <a:off x="548640" y="4892040"/>
+            <a:ext cx="11064240" cy="5120640"/>
           </a:xfrm>
           <a:prstGeom prst="rect">
             <a:avLst/>
@@ -5851,21 +5985,60 @@
           </a:bodyPr>
           <a:lstStyle/>
           <a:p>
-            <a:r>
-              <a:rPr sz="1200" b="0" i="1">
+            <a:pPr>
+              <a:spcAft>
+                <a:spcPts val="800"/>
+              </a:spcAft>
+            </a:pPr>
+            <a:r>
+              <a:rPr sz="1500" b="1" i="0">
+                <a:solidFill>
+                  <a:srgbClr val="B00000"/>
+                </a:solidFill>
+                <a:latin typeface="Calibri"/>
+              </a:rPr>
+              <a:t>The rankings invert: </a:t>
+            </a:r>
+            <a:r>
+              <a:rPr sz="1500" b="0" i="0">
+                <a:solidFill>
+                  <a:srgbClr val="222222"/>
+                </a:solidFill>
+                <a:latin typeface="Calibri"/>
+              </a:rPr>
+              <a:t>fine-tuned BART — best on every reference-based metric — has 0% of sentences entailed by the transcript; prompted long-context LED, worst on ROUGE, is best-grounded (34%) because it copies the commentary it reads.</a:t>
+            </a:r>
+          </a:p>
+          <a:p>
+            <a:pPr>
+              <a:spcAft>
+                <a:spcPts val="800"/>
+              </a:spcAft>
+            </a:pPr>
+            <a:r>
+              <a:rPr sz="1500" b="1" i="0">
+                <a:solidFill>
+                  <a:srgbClr val="222222"/>
+                </a:solidFill>
+                <a:latin typeface="Calibri"/>
+              </a:rPr>
+              <a:t>Fine-tuning on GPT-4 references optimises agreement with the references at the expense of grounding in the input. </a:t>
+            </a:r>
+            <a:r>
+              <a:rPr sz="1300" b="0" i="0">
                 <a:solidFill>
                   <a:srgbClr val="666666"/>
                 </a:solidFill>
                 <a:latin typeface="Calibri"/>
               </a:rPr>
-              <a:t>LED fine-tuning after the fixes: val ROUGE-L peaks at 0.172 (epoch 9).</a:t>
-            </a:r>
-          </a:p>
-        </p:txBody>
-      </p:sp>
-      <p:sp>
-        <p:nvSpPr>
-          <p:cNvPr id="6" name="TextBox 5"/>
+              <a:t>(NLI rates are conservative lower bounds — register gap, ASR noise — so compare across conditions, not absolutely.)</a:t>
+            </a:r>
+          </a:p>
+        </p:txBody>
+      </p:sp>
+      <p:sp>
+        <p:nvSpPr>
+          <p:cNvPr id="5" name="TextBox 4"/>
           <p:cNvSpPr txBox="1"/>
           <p:nvPr/>
         </p:nvSpPr>

</xml_diff>

<commit_message>
Add PDF export of slides; fix chart/footnote overlap, gold->reference
Exported via Keynote. Rendering the PDF surfaced a footnote overlapping
the results chart (slide 5, image resized), two remaining 'gold' mentions
(slide 6), and a median/mean mismatch with the report (slide 2).

Co-Authored-By: Claude Fable 5 <noreply@anthropic.com>
</commit_message>
<xml_diff>
--- a/report/slides/ANLP_slides.pptx
+++ b/report/slides/ANLP_slides.pptx
@@ -3879,7 +3879,7 @@
                 </a:solidFill>
                 <a:latin typeface="Calibri"/>
               </a:rPr>
-              <a:t>Whisper transcript of live BBC Radio 5 commentary — median ~25,000 words, noisy, fragmented, full of irrelevant detail.</a:t>
+              <a:t>Whisper transcript of live BBC Radio 5 commentary — mean ~25,000 words, noisy, fragmented, full of irrelevant detail.</a:t>
             </a:r>
           </a:p>
           <a:p>
@@ -4883,8 +4883,8 @@
         </p:blipFill>
         <p:spPr>
           <a:xfrm>
-            <a:off x="1234440" y="1280160"/>
-            <a:ext cx="9692640" cy="5255046"/>
+            <a:off x="1892807" y="1234440"/>
+            <a:ext cx="8412480" cy="4560983"/>
           </a:xfrm>
           <a:prstGeom prst="rect">
             <a:avLst/>
@@ -4899,7 +4899,7 @@
         </p:nvSpPr>
         <p:spPr>
           <a:xfrm>
-            <a:off x="640080" y="6053328"/>
+            <a:off x="640080" y="5989320"/>
             <a:ext cx="10972800" cy="685800"/>
           </a:xfrm>
           <a:prstGeom prst="rect">
@@ -5084,7 +5084,7 @@
                 </a:solidFill>
                 <a:latin typeface="Calibri"/>
               </a:rPr>
-              <a:t>on (transcript[:1024] → gold) shows BART only the first ~5 minutes of a 2.5-hour match.</a:t>
+              <a:t>on (transcript[:1024] → reference) shows BART only the first ~5 minutes of a 2.5-hour match.</a:t>
             </a:r>
           </a:p>
           <a:p>
@@ -5109,7 +5109,7 @@
                 </a:solidFill>
                 <a:latin typeface="Calibri"/>
               </a:rPr>
-              <a:t>run pre-trained BART on every chunk → concatenate the ~30 mini-summaries (~960 tokens) → fine-tune BART to map that intermediate to the gold report. Training input now matches what the model sees at inference.</a:t>
+              <a:t>run pre-trained BART on every chunk → concatenate the ~30 mini-summaries (~960 tokens) → fine-tune BART to map that intermediate to the reference report. Training input now matches what the model sees at inference.</a:t>
             </a:r>
           </a:p>
           <a:p>

</xml_diff>

<commit_message>
Fix slide 8 BART quote to real run-4 output; cite PEGASUS/T5; competitions -> competition/stage categories; split abstract
- Slide 8 quoted the run-2 BART output for the 2001 final, contradicting the
  report's Table 6; now quotes the actual run-4 output on the 2019 UCL final,
  labelled with the true result, matching the report's example exactly
- Related Work: add zhang2020pegasus and raffel2020t5 citations
- '12 competitions' -> '12 competition/stage categories' (abstract, section 3.1,
  Table 1, slide 3 title), noting finals/qualifiers are counted separately
- Abstract split into two paragraphs after the dataset sentence

Co-Authored-By: Claude Fable 5 <noreply@anthropic.com>
</commit_message>
<xml_diff>
--- a/report/slides/ANLP_slides.pptx
+++ b/report/slides/ANLP_slides.pptx
@@ -4098,7 +4098,7 @@
                 </a:solidFill>
                 <a:latin typeface="Calibri"/>
               </a:rPr>
-              <a:t>A custom dataset: 99 matches, 43 years, 12 competitions</a:t>
+              <a:t>A custom dataset: 99 matches, 43 years, 12 competition categories</a:t>
             </a:r>
           </a:p>
           <a:p>
@@ -5597,7 +5597,7 @@
                 </a:solidFill>
                 <a:latin typeface="Calibri"/>
               </a:rPr>
-              <a:t>Test match: 2001 FA Cup Final — true result: Liverpool 2–1 Arsenal, Millennium Stadium</a:t>
+              <a:t>Real test-set outputs; each quote labelled with the true result</a:t>
             </a:r>
           </a:p>
         </p:txBody>
@@ -5651,7 +5651,7 @@
                 </a:solidFill>
                 <a:latin typeface="Calibri"/>
               </a:rPr>
-              <a:t>Fine-tuned BART (best model)</a:t>
+              <a:t>Fine-tuned BART (best model) — 2019 UCL Final (true: Liverpool 2–0 Tottenham, Madrid, no shootout)</a:t>
             </a:r>
           </a:p>
           <a:p>
@@ -5662,7 +5662,7 @@
                 </a:solidFill>
                 <a:latin typeface="Calibri"/>
               </a:rPr>
-              <a:t>“Liverpool 1–1 Arsenal (Liverpool win 2–3 on penalties) 20 May 2014 — Emirates Stadium, London. The match was contested … in the 2014 FA Cup Final…”</a:t>
+              <a:t>“Liverpool 2–2 Tottenham Hotspur (Liverpool win 4–3 on penalties) … 2023 UEFA Champions League Final, Wembley Stadium, London – 31 May 2019 … Liverpool secured a dramatic victory…”</a:t>
             </a:r>
           </a:p>
         </p:txBody>
@@ -5716,7 +5716,7 @@
                 </a:solidFill>
                 <a:latin typeface="Calibri"/>
               </a:rPr>
-              <a:t>Fine-tuned LED</a:t>
+              <a:t>Fine-tuned LED — 2001 FA Cup Final (true: Liverpool 2–1 Arsenal, Millennium Stadium)</a:t>
             </a:r>
           </a:p>
           <a:p>

</xml_diff>

<commit_message>
Task A: clean LED retrain (run5); update report and slides with new LED numbers
- run5 finetuned_led predictions bundled (runs/run5_led_clean_2026-05-04/)
- percondition_cis.csv regenerated: LED ROUGE-L 0.2480 vs BART 0.2476 (Delta=-0.0004, not significant)
- faithfulness.csv regenerated with run5 LED: 2/9 correct scores (up from 1/9), scorer recall 0.13
- LED now nominally rank 1 in leaderboard table; dagger caveat removed throughout
- Observation 2, abstract, conclusions, engineering section updated with run5 numbers
- Leaderboard, inversion, LED training curve figures regenerated
- make_slides.py and make_slides_alt.py updated; PPTX slides regenerated
- semantic.csv pending (compute_semantic.py re-run queued; values unlikely to change materially)

Co-Authored-By: Claude Opus 4.7 <noreply@anthropic.com>
</commit_message>
<xml_diff>
--- a/report/slides/ANLP_slides.pptx
+++ b/report/slides/ANLP_slides.pptx
@@ -3391,7 +3391,7 @@
         <p:spPr>
           <a:xfrm>
             <a:off x="6537960" y="1737360"/>
-            <a:ext cx="5212080" cy="2932191"/>
+            <a:ext cx="5212080" cy="2963856"/>
           </a:xfrm>
           <a:prstGeom prst="rect">
             <a:avLst/>
@@ -3694,7 +3694,7 @@
                 </a:solidFill>
                 <a:latin typeface="Calibri"/>
               </a:rPr>
-              <a:t>n = 9 test matches → bootstrap CIs resolve fine-tuning vs prompting (significant) but not BART vs LED (+0.029 [−0.014, +0.070]).</a:t>
+              <a:t>n = 9 test matches → bootstrap CIs resolve fine-tuning vs prompting (significant) but not LED vs BART (−0.0004 [−0.042, +0.035]).</a:t>
             </a:r>
           </a:p>
           <a:p>
@@ -3726,7 +3726,7 @@
                 </a:solidFill>
                 <a:latin typeface="Calibri"/>
               </a:rPr>
-              <a:t>NLI support rates are conservative lower bounds (ASR-noisy premises, register gap); entity precision is still unmeasured. LED was trained pre-fix (evaluation clean, training not).</a:t>
+              <a:t>NLI support rates are conservative lower bounds (ASR-noisy premises, register gap); entity precision is still unmeasured over all entity types.</a:t>
             </a:r>
           </a:p>
         </p:txBody>
@@ -4920,7 +4920,7 @@
                 </a:solidFill>
                 <a:latin typeface="Calibri"/>
               </a:rPr>
-              <a:t>Every prompting condition is significantly below fine-tuned BART (paired bootstrap; 95% CI of the difference excludes 0). The BART−LED gap (+0.029 [−0.014, +0.070]) is NOT significant.  * LED trained before the dataset fix; re-scored post-hoc on the same clean 9-match protocol.</a:t>
+              <a:t>Every prompting condition is significantly below both fine-tuned models (paired bootstrap; 95% CI of the difference excludes 0). The LED−BART gap (−0.0004 [−0.042, +0.035]) is NOT significant.</a:t>
             </a:r>
           </a:p>
         </p:txBody>
@@ -5376,7 +5376,7 @@
                 </a:solidFill>
                 <a:latin typeface="Calibri"/>
               </a:rPr>
-              <a:t>BART chunk-merger is nominally ahead (0.248 vs 0.219) but the paired difference is not significant at n = 9 — the two fine-tuned pipelines cannot be separated. LED is more consistent (narrow CI); BART has the higher ceiling (wide CI).</a:t>
+              <a:t>LED long-context is nominally ahead (0.248 vs 0.248) but the paired difference is not significant at n = 9 — the two fine-tuned pipelines cannot be separated. LED is more consistent (CI [0.230, 0.266]); BART has more variance (CI [0.208, 0.283]).</a:t>
             </a:r>
           </a:p>
           <a:p>
@@ -5408,7 +5408,7 @@
                 </a:solidFill>
                 <a:latin typeface="Calibri"/>
               </a:rPr>
-              <a:t>Why chunk-merger might really be ahead: sample efficiency at N = 80.</a:t>
+              <a:t>Why the two pipelines are statistically tied despite architectural differences:</a:t>
             </a:r>
           </a:p>
           <a:p>
@@ -5440,7 +5440,7 @@
                 </a:solidFill>
                 <a:latin typeface="Calibri"/>
               </a:rPr>
-              <a:t>LED must learn what matters inside raw 8,192-token windows from scratch — too few pairs to learn long-range attention patterns.</a:t>
+              <a:t>LED must learn what matters inside raw 8,192-token windows from scratch — too few pairs (N = 80) to learn long-range attention patterns reliably.</a:t>
             </a:r>
           </a:p>
           <a:p>
@@ -5775,7 +5775,7 @@
                 </a:solidFill>
                 <a:latin typeface="Calibri"/>
               </a:rPr>
-              <a:t>the ROUGE-best model (fine-tuned BART) states the correct final score in </a:t>
+              <a:t>fine-tuned BART (ROUGE rank 2) states the correct final score in </a:t>
             </a:r>
             <a:r>
               <a:rPr sz="1600" b="1" i="0">
@@ -5793,7 +5793,7 @@
                 </a:solidFill>
                 <a:latin typeface="Calibri"/>
               </a:rPr>
-              <a:t> and recalls only 30% of reference scorers. Fine-tuned LED: 1/9 scores, 15% scorers. Its scorelines are decorative — 1–1, 2–2, 1–0 regardless of the real 0–4, 3–0…</a:t>
+              <a:t> and recalls only 30% of reference scorers. Fine-tuned LED (ROUGE rank 1): 2/9 scores, 13% scorers. BART scorelines are decorative — 1–1, 2–2, 1–0 regardless of the real 0–4, 3–0…</a:t>
             </a:r>
           </a:p>
           <a:p>

</xml_diff>

<commit_message>
Update semantic.csv with run5 LED; fix report/slides for LED BERTScore > BART
- semantic.csv regenerated with run5 finetuned_led predictions:
  LED BERTScore 0.869 (up from 0.848), now > BART 0.860; NLI 0.016 (vs 0.031)
- LED now leads on all reference metrics (ROUGE-L, BERTScore)
- Tab semantic reordered; prose updated: LED top, BART extreme on NLI (0%)
- Conclusions bullet 3 rewritten to attribute 0/9 score failure to BART specifically
- Inversion slide text updated to reflect new semantic ordering on both decks

Co-Authored-By: Claude Opus 4.7 <noreply@anthropic.com>
</commit_message>
<xml_diff>
--- a/report/slides/ANLP_slides.pptx
+++ b/report/slides/ANLP_slides.pptx
@@ -3630,7 +3630,7 @@
                 </a:solidFill>
                 <a:latin typeface="Calibri"/>
               </a:rPr>
-              <a:t>— the ROUGE- and BERTScore-best model never states the correct score (0/9) and has 0% of sentences entailed by the transcript. Optimising a faithfulness signal, not just measuring one, is the natural next step.</a:t>
+              <a:t>— fine-tuned LED tops ROUGE-L and BERTScore yet achieves 2/9 correct scores and 2% NLI; BART goes further at 0/9 and 0% NLI. The transcript-copying prompted LED both outrank on ROUGE remains the best-grounded (34%). Optimising faithfulness, not just measuring it, is the next step.</a:t>
             </a:r>
           </a:p>
           <a:p>
@@ -6006,7 +6006,7 @@
                 </a:solidFill>
                 <a:latin typeface="Calibri"/>
               </a:rPr>
-              <a:t>fine-tuned BART — best on every reference-based metric — has 0% of sentences entailed by the transcript; prompted long-context LED, worst on ROUGE, is best-grounded (34%) because it copies the commentary it reads.</a:t>
+              <a:t>fine-tuned LED leads on ROUGE-L and BERTScore yet has only 2% NLI support; fine-tuned BART — zero NLI-supported sentences — is even more extreme. Prompted long-context LED, outranked on every reference metric, is the best-grounded condition (34%) because it copies the commentary.</a:t>
             </a:r>
           </a:p>
           <a:p>

</xml_diff>

<commit_message>
Fix all post-assessment issues: run5 training curve, abstract, intro, slides
- make_led_curve.py: switch hardcoded fallback from run3 to run5 (14 epochs,
  peak val ROUGE-L 0.270 at epoch 12, from kernel.log); regenerate figure
- main.tex: engineering text updated for run5 peak/epoch numbers; figure
  caption now describes run5; LED figure no longer labelled "run 3"
- main.tex: introduction contribution bullet 2 notes LED ties BART at 0.248
- main.tex: abstract strengthened — LED leads all reference metrics yet gets
  2/9 scores and 2% NLI; BART 0/9 and 0% NLI; full decoupling stated up front
- main.tex: conclusions bullet 3 rewritten (no awkward grammar)
- make_slides{,_alt}.py: slide 10 engineering bullet updated with run5 numbers;
  slide 11 conclusion bullet 3 wording fixed; both PPTXs regenerated

Co-Authored-By: Claude Opus 4.7 <noreply@anthropic.com>
</commit_message>
<xml_diff>
--- a/report/slides/ANLP_slides.pptx
+++ b/report/slides/ANLP_slides.pptx
@@ -3369,7 +3369,7 @@
                 </a:solidFill>
                 <a:latin typeface="Calibri"/>
               </a:rPr>
-              <a:t>After the fixes: a clean, monotone training curve → the earlier collapses were data and code defects, not modelling limits.</a:t>
+              <a:t>After the fixes (run 5, clean data): 14 epochs, val ROUGE-L peaks at 0.270 → test 0.248. Earlier collapses were data and code defects, not modelling limits.</a:t>
             </a:r>
           </a:p>
         </p:txBody>
@@ -3391,7 +3391,7 @@
         <p:spPr>
           <a:xfrm>
             <a:off x="6537960" y="1737360"/>
-            <a:ext cx="5212080" cy="2963856"/>
+            <a:ext cx="5212080" cy="2951190"/>
           </a:xfrm>
           <a:prstGeom prst="rect">
             <a:avLst/>
@@ -3427,7 +3427,7 @@
                 </a:solidFill>
                 <a:latin typeface="Calibri"/>
               </a:rPr>
-              <a:t>LED fine-tuning after the fixes: val ROUGE-L peaks at 0.172 (epoch 9).</a:t>
+              <a:t>LED run 5 (clean dataset): val ROUGE-L peaks at 0.270 (epoch 12) → test 0.248.</a:t>
             </a:r>
           </a:p>
         </p:txBody>
@@ -3630,7 +3630,7 @@
                 </a:solidFill>
                 <a:latin typeface="Calibri"/>
               </a:rPr>
-              <a:t>— fine-tuned LED tops ROUGE-L and BERTScore yet achieves 2/9 correct scores and 2% NLI; BART goes further at 0/9 and 0% NLI. The transcript-copying prompted LED both outrank on ROUGE remains the best-grounded (34%). Optimising faithfulness, not just measuring it, is the next step.</a:t>
+              <a:t>— fine-tuned LED leads every reference metric yet gets 2/9 scores and 2% NLI; BART is worse at 0/9 and 0% NLI. The prompted LED both outrank on ROUGE is the best-grounded condition (34%). Optimising faithfulness, not just measuring it, is the natural next step.</a:t>
             </a:r>
           </a:p>
           <a:p>

</xml_diff>